<commit_message>
Repo hygiene: strip name/address columns from derived files, untrack raw data
- data/processed/clean.csv and scored.csv (phase 1) no longer carry Title,
  First/Middle/Last Name, Suffix or Street Address columns; nothing
  downstream (v2_merge, app) used them. City-ZipCode-State kept (needed by
  v2_merge for State; city-level, not street).
- data/raw/ and the root raw customer CSV are untracked and gitignored so
  they can never be pushed again (files stay on disk).
- Review PPTX: slide 3 now reads 'Recency above 365 days (11 rows) kept:
  Churned either way' (files show max 400, kept as-is per C8); slide 5
  books by tier corrected to 4.1 -> 9.1 -> 20.2 (classified rows).
- v2 cheatsheet: genre wording now '26 raw spellings, 23 after basic
  tidying, merged into 8 genres' (both counts are true).
- App smoke-tested after the strip: Final Report page renders all KPIs
  and charts with no errors.
</commit_message>
<xml_diff>
--- a/eBook_Subscriber_Insights_Review (2).pptx
+++ b/eBook_Subscriber_Insights_Review (2).pptx
@@ -1935,6 +1935,10 @@
             <a:prstDash val="solid"/>
           </a:ln>
         </p:spPr>
+        <p:txBody>
+          <a:bodyPr/>
+          <a:p/>
+        </p:txBody>
       </p:sp>
       <p:sp>
         <p:nvSpPr>
@@ -1960,6 +1964,10 @@
             <a:prstDash val="solid"/>
           </a:ln>
         </p:spPr>
+        <p:txBody>
+          <a:bodyPr/>
+          <a:p/>
+        </p:txBody>
       </p:sp>
       <p:sp>
         <p:nvSpPr>
@@ -1985,6 +1993,10 @@
             <a:prstDash val="solid"/>
           </a:ln>
         </p:spPr>
+        <p:txBody>
+          <a:bodyPr/>
+          <a:p/>
+        </p:txBody>
       </p:sp>
       <p:sp>
         <p:nvSpPr>
@@ -2186,6 +2198,10 @@
             <a:prstDash val="solid"/>
           </a:ln>
         </p:spPr>
+        <p:txBody>
+          <a:bodyPr/>
+          <a:p/>
+        </p:txBody>
       </p:sp>
       <p:sp>
         <p:nvSpPr>
@@ -2371,6 +2387,10 @@
             <a:prstDash val="solid"/>
           </a:ln>
         </p:spPr>
+        <p:txBody>
+          <a:bodyPr/>
+          <a:p/>
+        </p:txBody>
       </p:sp>
       <p:sp>
         <p:nvSpPr>
@@ -2554,6 +2574,10 @@
             <a:prstDash val="solid"/>
           </a:ln>
         </p:spPr>
+        <p:txBody>
+          <a:bodyPr/>
+          <a:p/>
+        </p:txBody>
       </p:sp>
       <p:sp>
         <p:nvSpPr>
@@ -2581,6 +2605,10 @@
             <a:prstDash val="solid"/>
           </a:ln>
         </p:spPr>
+        <p:txBody>
+          <a:bodyPr/>
+          <a:p/>
+        </p:txBody>
       </p:sp>
       <p:sp>
         <p:nvSpPr>
@@ -2752,6 +2780,10 @@
             <a:prstDash val="solid"/>
           </a:ln>
         </p:spPr>
+        <p:txBody>
+          <a:bodyPr/>
+          <a:p/>
+        </p:txBody>
       </p:sp>
       <p:sp>
         <p:nvSpPr>
@@ -2854,6 +2886,10 @@
             <a:prstDash val="solid"/>
           </a:ln>
         </p:spPr>
+        <p:txBody>
+          <a:bodyPr/>
+          <a:p/>
+        </p:txBody>
       </p:sp>
       <p:sp>
         <p:nvSpPr>
@@ -2956,6 +2992,10 @@
             <a:prstDash val="solid"/>
           </a:ln>
         </p:spPr>
+        <p:txBody>
+          <a:bodyPr/>
+          <a:p/>
+        </p:txBody>
       </p:sp>
       <p:sp>
         <p:nvSpPr>
@@ -3058,6 +3098,10 @@
             <a:prstDash val="solid"/>
           </a:ln>
         </p:spPr>
+        <p:txBody>
+          <a:bodyPr/>
+          <a:p/>
+        </p:txBody>
       </p:sp>
       <p:sp>
         <p:nvSpPr>
@@ -3160,6 +3204,10 @@
             <a:prstDash val="solid"/>
           </a:ln>
         </p:spPr>
+        <p:txBody>
+          <a:bodyPr/>
+          <a:p/>
+        </p:txBody>
       </p:sp>
       <p:sp>
         <p:nvSpPr>
@@ -3345,6 +3393,10 @@
             <a:prstDash val="solid"/>
           </a:ln>
         </p:spPr>
+        <p:txBody>
+          <a:bodyPr/>
+          <a:p/>
+        </p:txBody>
       </p:sp>
       <p:sp>
         <p:nvSpPr>
@@ -3480,7 +3532,7 @@
                   <a:schemeClr val="tx1"/>
                 </a:solidFill>
               </a:rPr>
-              <a:t>Recency capped at 365 days</a:t>
+              <a:t>Recency above 365 days (11 rows) kept: Churned either way</a:t>
             </a:r>
             <a:endParaRPr lang="en-US" sz="1600" dirty="0"/>
           </a:p>
@@ -3728,6 +3780,10 @@
             <a:prstDash val="solid"/>
           </a:ln>
         </p:spPr>
+        <p:txBody>
+          <a:bodyPr/>
+          <a:p/>
+        </p:txBody>
       </p:sp>
       <p:sp>
         <p:nvSpPr>
@@ -3755,6 +3811,10 @@
             <a:prstDash val="solid"/>
           </a:ln>
         </p:spPr>
+        <p:txBody>
+          <a:bodyPr/>
+          <a:p/>
+        </p:txBody>
       </p:sp>
       <p:sp>
         <p:nvSpPr>
@@ -3818,6 +3878,10 @@
             <a:prstDash val="solid"/>
           </a:ln>
         </p:spPr>
+        <p:txBody>
+          <a:bodyPr/>
+          <a:p/>
+        </p:txBody>
       </p:sp>
       <p:sp>
         <p:nvSpPr>
@@ -3845,6 +3909,10 @@
             <a:prstDash val="solid"/>
           </a:ln>
         </p:spPr>
+        <p:txBody>
+          <a:bodyPr/>
+          <a:p/>
+        </p:txBody>
       </p:sp>
       <p:sp>
         <p:nvSpPr>
@@ -3908,6 +3976,10 @@
             <a:prstDash val="solid"/>
           </a:ln>
         </p:spPr>
+        <p:txBody>
+          <a:bodyPr/>
+          <a:p/>
+        </p:txBody>
       </p:sp>
       <p:sp>
         <p:nvSpPr>
@@ -3935,6 +4007,10 @@
             <a:prstDash val="solid"/>
           </a:ln>
         </p:spPr>
+        <p:txBody>
+          <a:bodyPr/>
+          <a:p/>
+        </p:txBody>
       </p:sp>
       <p:sp>
         <p:nvSpPr>
@@ -4074,6 +4150,10 @@
             <a:prstDash val="solid"/>
           </a:ln>
         </p:spPr>
+        <p:txBody>
+          <a:bodyPr/>
+          <a:p/>
+        </p:txBody>
       </p:sp>
       <p:sp>
         <p:nvSpPr>
@@ -4173,6 +4253,10 @@
             <a:prstDash val="solid"/>
           </a:ln>
         </p:spPr>
+        <p:txBody>
+          <a:bodyPr/>
+          <a:p/>
+        </p:txBody>
       </p:sp>
       <p:sp>
         <p:nvSpPr>
@@ -4272,6 +4356,10 @@
             <a:prstDash val="solid"/>
           </a:ln>
         </p:spPr>
+        <p:txBody>
+          <a:bodyPr/>
+          <a:p/>
+        </p:txBody>
       </p:sp>
       <p:sp>
         <p:nvSpPr>
@@ -4531,6 +4619,10 @@
             <a:prstDash val="solid"/>
           </a:ln>
         </p:spPr>
+        <p:txBody>
+          <a:bodyPr/>
+          <a:p/>
+        </p:txBody>
       </p:sp>
       <p:sp>
         <p:nvSpPr>
@@ -4633,6 +4725,10 @@
             <a:prstDash val="solid"/>
           </a:ln>
         </p:spPr>
+        <p:txBody>
+          <a:bodyPr/>
+          <a:p/>
+        </p:txBody>
       </p:sp>
       <p:sp>
         <p:nvSpPr>
@@ -4735,6 +4831,10 @@
             <a:prstDash val="solid"/>
           </a:ln>
         </p:spPr>
+        <p:txBody>
+          <a:bodyPr/>
+          <a:p/>
+        </p:txBody>
       </p:sp>
       <p:sp>
         <p:nvSpPr>
@@ -4769,7 +4869,7 @@
                 <a:ea typeface="Trebuchet MS" pitchFamily="34" charset="-122"/>
                 <a:cs typeface="Trebuchet MS" pitchFamily="34" charset="-120"/>
               </a:rPr>
-              <a:t>4.2 → 9.1 → 20.3 books</a:t>
+              <a:t>4.1 → 9.1 → 20.2 books</a:t>
             </a:r>
             <a:endParaRPr lang="en-US" sz="2300" dirty="0"/>
           </a:p>
@@ -4981,6 +5081,10 @@
             <a:prstDash val="solid"/>
           </a:ln>
         </p:spPr>
+        <p:txBody>
+          <a:bodyPr/>
+          <a:p/>
+        </p:txBody>
       </p:sp>
       <p:sp>
         <p:nvSpPr>
@@ -5166,6 +5270,10 @@
             <a:prstDash val="solid"/>
           </a:ln>
         </p:spPr>
+        <p:txBody>
+          <a:bodyPr/>
+          <a:p/>
+        </p:txBody>
       </p:sp>
       <p:sp>
         <p:nvSpPr>
@@ -5329,6 +5437,10 @@
             <a:prstDash val="solid"/>
           </a:ln>
         </p:spPr>
+        <p:txBody>
+          <a:bodyPr/>
+          <a:p/>
+        </p:txBody>
       </p:sp>
       <p:sp>
         <p:nvSpPr>
@@ -5428,6 +5540,10 @@
             <a:prstDash val="solid"/>
           </a:ln>
         </p:spPr>
+        <p:txBody>
+          <a:bodyPr/>
+          <a:p/>
+        </p:txBody>
       </p:sp>
       <p:sp>
         <p:nvSpPr>
@@ -5527,6 +5643,10 @@
             <a:prstDash val="solid"/>
           </a:ln>
         </p:spPr>
+        <p:txBody>
+          <a:bodyPr/>
+          <a:p/>
+        </p:txBody>
       </p:sp>
       <p:sp>
         <p:nvSpPr>
@@ -5734,6 +5854,10 @@
             <a:prstDash val="solid"/>
           </a:ln>
         </p:spPr>
+        <p:txBody>
+          <a:bodyPr/>
+          <a:p/>
+        </p:txBody>
       </p:sp>
       <p:sp>
         <p:nvSpPr>
@@ -5955,6 +6079,10 @@
             <a:prstDash val="solid"/>
           </a:ln>
         </p:spPr>
+        <p:txBody>
+          <a:bodyPr/>
+          <a:p/>
+        </p:txBody>
       </p:sp>
       <p:sp>
         <p:nvSpPr>

</xml_diff>